<commit_message>
debug: add trace output to SplitKVLayout.reshape
</commit_message>
<xml_diff>
--- a/docs/vllm-ascend-KV cache管理优化方案.pptx
+++ b/docs/vllm-ascend-KV cache管理优化方案.pptx
@@ -8,10 +8,10 @@
     <p:sldMasterId id="2147483683" r:id="rId4"/>
   </p:sldMasterIdLst>
   <p:notesMasterIdLst>
-    <p:notesMasterId r:id="rId32"/>
+    <p:notesMasterId r:id="rId33"/>
   </p:notesMasterIdLst>
   <p:handoutMasterIdLst>
-    <p:handoutMasterId r:id="rId33"/>
+    <p:handoutMasterId r:id="rId34"/>
   </p:handoutMasterIdLst>
   <p:sldIdLst>
     <p:sldId id="283" r:id="rId5"/>
@@ -22,26 +22,26 @@
     <p:sldId id="326" r:id="rId10"/>
     <p:sldId id="325" r:id="rId11"/>
     <p:sldId id="324" r:id="rId12"/>
-    <p:sldId id="347" r:id="rId38"/>
-    <p:sldId id="328" r:id="rId13"/>
-    <p:sldId id="329" r:id="rId14"/>
-    <p:sldId id="330" r:id="rId15"/>
-    <p:sldId id="331" r:id="rId16"/>
-    <p:sldId id="332" r:id="rId17"/>
-    <p:sldId id="333" r:id="rId18"/>
-    <p:sldId id="334" r:id="rId19"/>
-    <p:sldId id="335" r:id="rId20"/>
-    <p:sldId id="336" r:id="rId21"/>
-    <p:sldId id="337" r:id="rId22"/>
-    <p:sldId id="339" r:id="rId23"/>
-    <p:sldId id="338" r:id="rId24"/>
-    <p:sldId id="340" r:id="rId25"/>
-    <p:sldId id="341" r:id="rId26"/>
-    <p:sldId id="342" r:id="rId27"/>
-    <p:sldId id="343" r:id="rId28"/>
-    <p:sldId id="344" r:id="rId29"/>
-    <p:sldId id="345" r:id="rId30"/>
-    <p:sldId id="280" r:id="rId31"/>
+    <p:sldId id="347" r:id="rId13"/>
+    <p:sldId id="328" r:id="rId14"/>
+    <p:sldId id="329" r:id="rId15"/>
+    <p:sldId id="330" r:id="rId16"/>
+    <p:sldId id="331" r:id="rId17"/>
+    <p:sldId id="332" r:id="rId18"/>
+    <p:sldId id="333" r:id="rId19"/>
+    <p:sldId id="334" r:id="rId20"/>
+    <p:sldId id="335" r:id="rId21"/>
+    <p:sldId id="336" r:id="rId22"/>
+    <p:sldId id="337" r:id="rId23"/>
+    <p:sldId id="339" r:id="rId24"/>
+    <p:sldId id="338" r:id="rId25"/>
+    <p:sldId id="340" r:id="rId26"/>
+    <p:sldId id="341" r:id="rId27"/>
+    <p:sldId id="342" r:id="rId28"/>
+    <p:sldId id="343" r:id="rId29"/>
+    <p:sldId id="344" r:id="rId30"/>
+    <p:sldId id="345" r:id="rId31"/>
+    <p:sldId id="280" r:id="rId32"/>
   </p:sldIdLst>
   <p:sldSz cx="12196763" cy="6858000"/>
   <p:notesSz cx="6858000" cy="9144000"/>
@@ -160,6 +160,7 @@
             <p14:sldId id="326"/>
             <p14:sldId id="325"/>
             <p14:sldId id="324"/>
+            <p14:sldId id="347"/>
             <p14:sldId id="328"/>
             <p14:sldId id="329"/>
             <p14:sldId id="330"/>
@@ -291,7 +292,7 @@
           <a:p>
             <a:fld id="{E8CF71B8-DF2A-2E41-BE66-2E18A767DA8A}" type="datetimeFigureOut">
               <a:rPr lang="en-US" smtClean="0"/>
-              <a:t>7/8/2026</a:t>
+              <a:t>7/10/2026</a:t>
             </a:fld>
             <a:endParaRPr lang="en-US"/>
           </a:p>
@@ -468,7 +469,7 @@
           <a:p>
             <a:fld id="{0DD60A27-BF12-6744-9E93-932A0E34D8BB}" type="datetimeFigureOut">
               <a:rPr lang="en-US" smtClean="0"/>
-              <a:t>6/26/2026</a:t>
+              <a:t>7/10/2026</a:t>
             </a:fld>
             <a:endParaRPr lang="en-US"/>
           </a:p>
@@ -889,7 +890,7 @@
           <a:p>
             <a:fld id="{F07326F3-4732-B74B-9C70-D0992466E499}" type="slidenum">
               <a:rPr lang="en-US" smtClean="0"/>
-              <a:t>27</a:t>
+              <a:t>28</a:t>
             </a:fld>
             <a:endParaRPr lang="en-US"/>
           </a:p>
@@ -21604,15 +21605,27 @@
       </p:sp>
       <p:graphicFrame>
         <p:nvGraphicFramePr>
-          <p:cNvPr id="30" name="Table 29"/>
+          <p:cNvPr id="2" name="Table 29">
+            <a:extLst>
+              <a:ext uri="{FF2B5EF4-FFF2-40B4-BE49-F238E27FC236}">
+                <a16:creationId xmlns:a16="http://schemas.microsoft.com/office/drawing/2014/main" id="{BCE6E82F-1B40-FA78-E9FF-9BDDF0FDD3A5}"/>
+              </a:ext>
+            </a:extLst>
+          </p:cNvPr>
           <p:cNvGraphicFramePr>
             <a:graphicFrameLocks noGrp="1"/>
           </p:cNvGraphicFramePr>
-          <p:nvPr/>
+          <p:nvPr>
+            <p:extLst>
+              <p:ext uri="{D42A27DB-BD31-4B8C-83A1-F6EECF244321}">
+                <p14:modId xmlns:p14="http://schemas.microsoft.com/office/powerpoint/2010/main" val="3155840426"/>
+              </p:ext>
+            </p:extLst>
+          </p:nvPr>
         </p:nvGraphicFramePr>
         <p:xfrm>
-          <a:off x="274320" y="749808"/>
-          <a:ext cx="11612880" cy="3108960"/>
+          <a:off x="121920" y="594357"/>
+          <a:ext cx="11884152" cy="3209040"/>
         </p:xfrm>
         <a:graphic>
           <a:graphicData uri="http://schemas.openxmlformats.org/drawingml/2006/table">
@@ -21621,16 +21634,64 @@
                 <a:tableStyleId>{5C22544A-7EE6-4342-B048-85BDC9FD1C3A}</a:tableStyleId>
               </a:tblPr>
               <a:tblGrid>
-                <a:gridCol w="1451610"/>
-                <a:gridCol w="1451610"/>
-                <a:gridCol w="1451610"/>
-                <a:gridCol w="1451610"/>
-                <a:gridCol w="1451610"/>
-                <a:gridCol w="1451610"/>
-                <a:gridCol w="1451610"/>
-                <a:gridCol w="1451610"/>
+                <a:gridCol w="1485519">
+                  <a:extLst>
+                    <a:ext uri="{9D8B030D-6E8A-4147-A177-3AD203B41FA5}">
+                      <a16:colId xmlns:a16="http://schemas.microsoft.com/office/drawing/2014/main" val="20000"/>
+                    </a:ext>
+                  </a:extLst>
+                </a:gridCol>
+                <a:gridCol w="1485519">
+                  <a:extLst>
+                    <a:ext uri="{9D8B030D-6E8A-4147-A177-3AD203B41FA5}">
+                      <a16:colId xmlns:a16="http://schemas.microsoft.com/office/drawing/2014/main" val="20001"/>
+                    </a:ext>
+                  </a:extLst>
+                </a:gridCol>
+                <a:gridCol w="1485519">
+                  <a:extLst>
+                    <a:ext uri="{9D8B030D-6E8A-4147-A177-3AD203B41FA5}">
+                      <a16:colId xmlns:a16="http://schemas.microsoft.com/office/drawing/2014/main" val="20002"/>
+                    </a:ext>
+                  </a:extLst>
+                </a:gridCol>
+                <a:gridCol w="1485519">
+                  <a:extLst>
+                    <a:ext uri="{9D8B030D-6E8A-4147-A177-3AD203B41FA5}">
+                      <a16:colId xmlns:a16="http://schemas.microsoft.com/office/drawing/2014/main" val="20003"/>
+                    </a:ext>
+                  </a:extLst>
+                </a:gridCol>
+                <a:gridCol w="1485519">
+                  <a:extLst>
+                    <a:ext uri="{9D8B030D-6E8A-4147-A177-3AD203B41FA5}">
+                      <a16:colId xmlns:a16="http://schemas.microsoft.com/office/drawing/2014/main" val="20004"/>
+                    </a:ext>
+                  </a:extLst>
+                </a:gridCol>
+                <a:gridCol w="1485519">
+                  <a:extLst>
+                    <a:ext uri="{9D8B030D-6E8A-4147-A177-3AD203B41FA5}">
+                      <a16:colId xmlns:a16="http://schemas.microsoft.com/office/drawing/2014/main" val="20005"/>
+                    </a:ext>
+                  </a:extLst>
+                </a:gridCol>
+                <a:gridCol w="1485519">
+                  <a:extLst>
+                    <a:ext uri="{9D8B030D-6E8A-4147-A177-3AD203B41FA5}">
+                      <a16:colId xmlns:a16="http://schemas.microsoft.com/office/drawing/2014/main" val="20006"/>
+                    </a:ext>
+                  </a:extLst>
+                </a:gridCol>
+                <a:gridCol w="1485519">
+                  <a:extLst>
+                    <a:ext uri="{9D8B030D-6E8A-4147-A177-3AD203B41FA5}">
+                      <a16:colId xmlns:a16="http://schemas.microsoft.com/office/drawing/2014/main" val="20007"/>
+                    </a:ext>
+                  </a:extLst>
+                </a:gridCol>
               </a:tblGrid>
-              <a:tr h="518160">
+              <a:tr h="534840">
                 <a:tc>
                   <a:txBody>
                     <a:bodyPr/>
@@ -21823,8 +21884,13 @@
                     </a:solidFill>
                   </a:tcPr>
                 </a:tc>
+                <a:extLst>
+                  <a:ext uri="{0D108BD9-81ED-4DB2-BD59-A6C34878D82A}">
+                    <a16:rowId xmlns:a16="http://schemas.microsoft.com/office/drawing/2014/main" val="10000"/>
+                  </a:ext>
+                </a:extLst>
               </a:tr>
-              <a:tr h="518160">
+              <a:tr h="534840">
                 <a:tc>
                   <a:txBody>
                     <a:bodyPr/>
@@ -22041,8 +22107,13 @@
                     </a:solidFill>
                   </a:tcPr>
                 </a:tc>
+                <a:extLst>
+                  <a:ext uri="{0D108BD9-81ED-4DB2-BD59-A6C34878D82A}">
+                    <a16:rowId xmlns:a16="http://schemas.microsoft.com/office/drawing/2014/main" val="10001"/>
+                  </a:ext>
+                </a:extLst>
               </a:tr>
-              <a:tr h="518160">
+              <a:tr h="534840">
                 <a:tc>
                   <a:txBody>
                     <a:bodyPr/>
@@ -22267,8 +22338,13 @@
                     </a:solidFill>
                   </a:tcPr>
                 </a:tc>
+                <a:extLst>
+                  <a:ext uri="{0D108BD9-81ED-4DB2-BD59-A6C34878D82A}">
+                    <a16:rowId xmlns:a16="http://schemas.microsoft.com/office/drawing/2014/main" val="10002"/>
+                  </a:ext>
+                </a:extLst>
               </a:tr>
-              <a:tr h="518160">
+              <a:tr h="534840">
                 <a:tc>
                   <a:txBody>
                     <a:bodyPr/>
@@ -22493,8 +22569,13 @@
                     </a:solidFill>
                   </a:tcPr>
                 </a:tc>
+                <a:extLst>
+                  <a:ext uri="{0D108BD9-81ED-4DB2-BD59-A6C34878D82A}">
+                    <a16:rowId xmlns:a16="http://schemas.microsoft.com/office/drawing/2014/main" val="10003"/>
+                  </a:ext>
+                </a:extLst>
               </a:tr>
-              <a:tr h="518160">
+              <a:tr h="534840">
                 <a:tc>
                   <a:txBody>
                     <a:bodyPr/>
@@ -22719,8 +22800,13 @@
                     </a:solidFill>
                   </a:tcPr>
                 </a:tc>
+                <a:extLst>
+                  <a:ext uri="{0D108BD9-81ED-4DB2-BD59-A6C34878D82A}">
+                    <a16:rowId xmlns:a16="http://schemas.microsoft.com/office/drawing/2014/main" val="10004"/>
+                  </a:ext>
+                </a:extLst>
               </a:tr>
-              <a:tr h="518160">
+              <a:tr h="534840">
                 <a:tc>
                   <a:txBody>
                     <a:bodyPr/>
@@ -22931,12 +23017,21 @@
                         </a:defRPr>
                       </a:pPr>
                       <a:r>
-                        <a:t>★★★★★ attn+mamba</a:t>
+                        <a:rPr dirty="0"/>
+                        <a:t>★★★★★ </a:t>
                       </a:r>
-                      <a:br/>
                       <a:r>
+                        <a:rPr dirty="0" err="1"/>
+                        <a:t>attn+mamba</a:t>
+                      </a:r>
+                      <a:br>
+                        <a:rPr dirty="0"/>
+                      </a:br>
+                      <a:r>
+                        <a:rPr dirty="0" err="1"/>
                         <a:t>layout互斥</a:t>
                       </a:r>
+                      <a:endParaRPr dirty="0"/>
                     </a:p>
                   </a:txBody>
                   <a:tcPr>
@@ -22945,6 +23040,11 @@
                     </a:solidFill>
                   </a:tcPr>
                 </a:tc>
+                <a:extLst>
+                  <a:ext uri="{0D108BD9-81ED-4DB2-BD59-A6C34878D82A}">
+                    <a16:rowId xmlns:a16="http://schemas.microsoft.com/office/drawing/2014/main" val="10005"/>
+                  </a:ext>
+                </a:extLst>
               </a:tr>
             </a:tbl>
           </a:graphicData>
@@ -28466,7 +28566,7 @@
         </p:nvSpPr>
         <p:spPr>
           <a:xfrm>
-            <a:off x="4937760" y="3573019"/>
+            <a:off x="4881563" y="3517965"/>
             <a:ext cx="6858000" cy="348813"/>
           </a:xfrm>
           <a:prstGeom prst="rect">
@@ -28497,7 +28597,7 @@
             </a:r>
             <a:r>
               <a:rPr dirty="0" err="1"/>
-              <a:t>种模型类型完整链路对比</a:t>
+              <a:t>种模型类型链路对比</a:t>
             </a:r>
             <a:br>
               <a:rPr dirty="0"/>
@@ -28633,7 +28733,7 @@
         </p:nvSpPr>
         <p:spPr>
           <a:xfrm>
-            <a:off x="4937760" y="4114821"/>
+            <a:off x="4945572" y="4169357"/>
             <a:ext cx="6858000" cy="348813"/>
           </a:xfrm>
           <a:prstGeom prst="rect">
@@ -28679,13 +28779,8 @@
             </a:r>
             <a:r>
               <a:rPr dirty="0"/>
-              <a:t> · </a:t>
-            </a:r>
-            <a:r>
-              <a:rPr dirty="0" err="1"/>
-              <a:t>三步路线图</a:t>
-            </a:r>
-            <a:endParaRPr dirty="0"/>
+              <a:t> </a:t>
+            </a:r>
           </a:p>
         </p:txBody>
       </p:sp>
@@ -32881,7 +32976,7 @@
         <p:spPr>
           <a:xfrm>
             <a:off x="121920" y="95504"/>
-            <a:ext cx="10972800" cy="457200"/>
+            <a:ext cx="10972800" cy="513026"/>
           </a:xfrm>
           <a:prstGeom prst="rect">
             <a:avLst/>
@@ -32907,9 +33002,19 @@
             </a:pPr>
             <a:r>
               <a:rPr dirty="0" err="1"/>
-              <a:t>六大根因，归结为两个源头</a:t>
-            </a:r>
-            <a:endParaRPr dirty="0"/>
+              <a:t>根因</a:t>
+            </a:r>
+            <a:r>
+              <a:rPr lang="zh-CN" altLang="en-US" dirty="0">
+                <a:latin typeface="微软雅黑" panose="020B0503020204020204" pitchFamily="34" charset="-122"/>
+                <a:ea typeface="微软雅黑" panose="020B0503020204020204" pitchFamily="34" charset="-122"/>
+              </a:rPr>
+              <a:t>和源头</a:t>
+            </a:r>
+            <a:endParaRPr dirty="0">
+              <a:latin typeface="微软雅黑" panose="020B0503020204020204" pitchFamily="34" charset="-122"/>
+              <a:ea typeface="微软雅黑" panose="020B0503020204020204" pitchFamily="34" charset="-122"/>
+            </a:endParaRPr>
           </a:p>
         </p:txBody>
       </p:sp>
@@ -33457,12 +33562,7 @@
               </a:defRPr>
             </a:pPr>
             <a:r>
-              <a:rPr>
-                <a:solidFill>
-                  <a:srgbClr val="C60054"/>
-                </a:solidFill>
-              </a:rPr>
-              <a:t>3. Spec 万能类: 类型擦除</a:t>
+              <a:t>3. Sparse 多 Tensor</a:t>
             </a:r>
           </a:p>
         </p:txBody>
@@ -33513,7 +33613,7 @@
               </a:defRPr>
             </a:pPr>
             <a:r>
-              <a:t>5种MLA变体→1个AscendMLAAttentionSpec。isinstance()不编码语义，下游用if-else恢复已丢失的类型信息。</a:t>
+              <a:t>aclnnSparseFlashAttention 需要3~4独立tensor输入。host侧预拆分 → allocate/reshape复杂化。</a:t>
             </a:r>
           </a:p>
         </p:txBody>
@@ -34267,7 +34367,7 @@
             </a:r>
             <a:r>
               <a:rPr dirty="0" err="1"/>
-              <a:t>三个根本源头</a:t>
+              <a:t>根本源头</a:t>
             </a:r>
             <a:endParaRPr dirty="0"/>
           </a:p>
@@ -34288,7 +34388,7 @@
         <p:spPr>
           <a:xfrm>
             <a:off x="452119" y="3954847"/>
-            <a:ext cx="11050863" cy="348813"/>
+            <a:ext cx="11050863" cy="477054"/>
           </a:xfrm>
           <a:prstGeom prst="rect">
             <a:avLst/>
@@ -34363,8 +34463,76 @@
               </a:defRPr>
             </a:pPr>
             <a:r>
-              <a:rPr dirty="0" err="1"/>
-              <a:t>硬件约束: NPU算子不支持stride访问 → host侧必须预拆分tensor → 分配和重塑逻辑复杂化 (根因1,2,4,5)。Spec 设计: 类型不编码语义 → isinstance()无区分力 → 下游被迫用if-else恢复丢失的类型信息 (根因3)。接口缺陷: get_kv_cache_shape() 单返回值无法表达多tensor布局 → 信息泄漏到 model_runner (根因6)。</a:t>
+              <a:rPr lang="en-US" altLang="zh-CN" dirty="0"/>
+              <a:t>Spec </a:t>
+            </a:r>
+            <a:r>
+              <a:rPr lang="zh-CN" altLang="en-US" dirty="0"/>
+              <a:t>设计</a:t>
+            </a:r>
+            <a:r>
+              <a:rPr lang="en-US" altLang="zh-CN" dirty="0"/>
+              <a:t>: </a:t>
+            </a:r>
+            <a:r>
+              <a:rPr lang="zh-CN" altLang="en-US" dirty="0"/>
+              <a:t>类型不编码语义 → </a:t>
+            </a:r>
+            <a:r>
+              <a:rPr lang="en-US" altLang="zh-CN" dirty="0" err="1"/>
+              <a:t>isinstance</a:t>
+            </a:r>
+            <a:r>
+              <a:rPr lang="en-US" altLang="zh-CN" dirty="0"/>
+              <a:t>()</a:t>
+            </a:r>
+            <a:r>
+              <a:rPr lang="zh-CN" altLang="en-US" dirty="0"/>
+              <a:t>无区分力 → 下游被迫用</a:t>
+            </a:r>
+            <a:r>
+              <a:rPr lang="en-US" altLang="zh-CN" dirty="0"/>
+              <a:t>if-else</a:t>
+            </a:r>
+            <a:r>
+              <a:rPr lang="zh-CN" altLang="en-US" dirty="0"/>
+              <a:t>恢复丢失的类型信息 </a:t>
+            </a:r>
+            <a:r>
+              <a:rPr lang="en-US" altLang="zh-CN" dirty="0"/>
+              <a:t>(</a:t>
+            </a:r>
+            <a:r>
+              <a:rPr lang="zh-CN" altLang="en-US" dirty="0"/>
+              <a:t>根因</a:t>
+            </a:r>
+            <a:r>
+              <a:rPr lang="en-US" altLang="zh-CN" dirty="0"/>
+              <a:t>3)</a:t>
+            </a:r>
+            <a:r>
+              <a:rPr lang="zh-CN" altLang="en-US" dirty="0"/>
+              <a:t>。</a:t>
+            </a:r>
+            <a:endParaRPr lang="en-US" dirty="0"/>
+          </a:p>
+          <a:p>
+            <a:pPr marL="171450" indent="-171450" algn="l">
+              <a:lnSpc>
+                <a:spcPts val="1019"/>
+              </a:lnSpc>
+              <a:buFont typeface="Wingdings" panose="05000000000000000000" pitchFamily="2" charset="2"/>
+              <a:buChar char="Ø"/>
+              <a:defRPr sz="850" b="0">
+                <a:solidFill>
+                  <a:srgbClr val="595757"/>
+                </a:solidFill>
+                <a:latin typeface="Microsoft YaHei"/>
+              </a:defRPr>
+            </a:pPr>
+            <a:r>
+              <a:rPr dirty="0" err="1"/>
+              <a:t>接口缺陷</a:t>
             </a:r>
             <a:r>
               <a:rPr dirty="0"/>
@@ -43691,8 +43859,8 @@
         </p:nvSpPr>
         <p:spPr>
           <a:xfrm>
-            <a:off x="684442" y="1729211"/>
-            <a:ext cx="10972800" cy="731520"/>
+            <a:off x="73152" y="1729211"/>
+            <a:ext cx="11657242" cy="579646"/>
           </a:xfrm>
           <a:prstGeom prst="rect">
             <a:avLst/>
@@ -43717,7 +43885,12 @@
               </a:defRPr>
             </a:pPr>
             <a:r>
-              <a:t>端到端管线全景：Spec → Backend → Allocate → Reshape</a:t>
+              <a:rPr dirty="0" err="1"/>
+              <a:t>端到端管线全景：Spec</a:t>
+            </a:r>
+            <a:r>
+              <a:rPr dirty="0"/>
+              <a:t> → Backend → Allocate → Reshape</a:t>
             </a:r>
           </a:p>
         </p:txBody>
@@ -43736,7 +43909,7 @@
         </p:nvSpPr>
         <p:spPr>
           <a:xfrm>
-            <a:off x="1746504" y="3200400"/>
+            <a:off x="1746504" y="2743200"/>
             <a:ext cx="2011680" cy="457200"/>
           </a:xfrm>
           <a:prstGeom prst="rect">
@@ -43781,7 +43954,7 @@
         </p:nvSpPr>
         <p:spPr>
           <a:xfrm>
-            <a:off x="1746504" y="3657600"/>
+            <a:off x="1746504" y="3200400"/>
             <a:ext cx="2011680" cy="381000"/>
           </a:xfrm>
           <a:prstGeom prst="rect">
@@ -43830,7 +44003,7 @@
         </p:nvSpPr>
         <p:spPr>
           <a:xfrm>
-            <a:off x="4123944" y="3200400"/>
+            <a:off x="4123944" y="2743200"/>
             <a:ext cx="2011680" cy="457200"/>
           </a:xfrm>
           <a:prstGeom prst="rect">
@@ -43875,7 +44048,7 @@
         </p:nvSpPr>
         <p:spPr>
           <a:xfrm>
-            <a:off x="4123944" y="3657600"/>
+            <a:off x="4123944" y="3200400"/>
             <a:ext cx="2011680" cy="381000"/>
           </a:xfrm>
           <a:prstGeom prst="rect">
@@ -43924,7 +44097,7 @@
         </p:nvSpPr>
         <p:spPr>
           <a:xfrm>
-            <a:off x="6501384" y="3200400"/>
+            <a:off x="6501384" y="2743200"/>
             <a:ext cx="2011680" cy="457200"/>
           </a:xfrm>
           <a:prstGeom prst="rect">
@@ -43969,7 +44142,7 @@
         </p:nvSpPr>
         <p:spPr>
           <a:xfrm>
-            <a:off x="6501384" y="3657600"/>
+            <a:off x="6501384" y="3200400"/>
             <a:ext cx="2011680" cy="381000"/>
           </a:xfrm>
           <a:prstGeom prst="rect">
@@ -44014,7 +44187,7 @@
         </p:nvSpPr>
         <p:spPr>
           <a:xfrm>
-            <a:off x="8878824" y="3200400"/>
+            <a:off x="8878824" y="2743200"/>
             <a:ext cx="2011680" cy="457200"/>
           </a:xfrm>
           <a:prstGeom prst="rect">
@@ -44059,7 +44232,7 @@
         </p:nvSpPr>
         <p:spPr>
           <a:xfrm>
-            <a:off x="8878824" y="3657600"/>
+            <a:off x="8878824" y="3200400"/>
             <a:ext cx="2011680" cy="381000"/>
           </a:xfrm>
           <a:prstGeom prst="rect">
@@ -44916,7 +45089,7 @@
         </p:nvSpPr>
         <p:spPr>
           <a:xfrm>
-            <a:off x="426720" y="1935480"/>
+            <a:off x="426720" y="1926500"/>
             <a:ext cx="2682240" cy="1416734"/>
           </a:xfrm>
           <a:prstGeom prst="rect">
@@ -45128,6 +45301,18 @@
             <a:r>
               <a:rPr dirty="0" err="1"/>
               <a:t>对象，不用问是什么模型</a:t>
+            </a:r>
+            <a:r>
+              <a:rPr lang="en-US" dirty="0"/>
+              <a:t>(</a:t>
+            </a:r>
+            <a:r>
+              <a:rPr lang="zh-CN" altLang="en-US" dirty="0"/>
+              <a:t>类型即语义</a:t>
+            </a:r>
+            <a:r>
+              <a:rPr lang="en-US" dirty="0"/>
+              <a:t>)</a:t>
             </a:r>
             <a:endParaRPr dirty="0"/>
           </a:p>
@@ -45653,7 +45838,7 @@
         <p:spPr>
           <a:xfrm>
             <a:off x="6172200" y="1929758"/>
-            <a:ext cx="3002280" cy="1416734"/>
+            <a:ext cx="2750820" cy="1609095"/>
           </a:xfrm>
           <a:prstGeom prst="rect">
             <a:avLst/>
@@ -45686,29 +45871,58 @@
               </a:defRPr>
             </a:pPr>
             <a:r>
-              <a:rPr dirty="0" err="1"/>
+              <a:rPr lang="zh-CN" altLang="en-US" dirty="0">
+                <a:latin typeface="微软雅黑" panose="020B0503020204020204" pitchFamily="34" charset="-122"/>
+                <a:ea typeface="微软雅黑" panose="020B0503020204020204" pitchFamily="34" charset="-122"/>
+              </a:rPr>
               <a:t>分组</a:t>
             </a:r>
             <a:r>
-              <a:rPr dirty="0"/>
+              <a:rPr lang="en-US" altLang="zh-CN" dirty="0">
+                <a:latin typeface="微软雅黑" panose="020B0503020204020204" pitchFamily="34" charset="-122"/>
+                <a:ea typeface="微软雅黑" panose="020B0503020204020204" pitchFamily="34" charset="-122"/>
+              </a:rPr>
               <a:t>: </a:t>
             </a:r>
             <a:r>
-              <a:rPr dirty="0" err="1"/>
+              <a:rPr lang="en-US" altLang="zh-CN" dirty="0" err="1">
+                <a:latin typeface="微软雅黑" panose="020B0503020204020204" pitchFamily="34" charset="-122"/>
+                <a:ea typeface="微软雅黑" panose="020B0503020204020204" pitchFamily="34" charset="-122"/>
+              </a:rPr>
               <a:t>get_kv_cache_groups</a:t>
             </a:r>
             <a:r>
-              <a:rPr dirty="0"/>
+              <a:rPr lang="en-US" altLang="zh-CN" dirty="0">
+                <a:latin typeface="微软雅黑" panose="020B0503020204020204" pitchFamily="34" charset="-122"/>
+                <a:ea typeface="微软雅黑" panose="020B0503020204020204" pitchFamily="34" charset="-122"/>
+              </a:rPr>
               <a:t>() — </a:t>
             </a:r>
             <a:r>
-              <a:rPr dirty="0" err="1"/>
-              <a:t>决策级联</a:t>
-            </a:r>
-            <a:r>
-              <a:rPr dirty="0"/>
-              <a:t> (Uniform→Hybrid→DSV4)</a:t>
-            </a:r>
+              <a:rPr lang="zh-CN" altLang="en-US" dirty="0">
+                <a:latin typeface="微软雅黑" panose="020B0503020204020204" pitchFamily="34" charset="-122"/>
+                <a:ea typeface="微软雅黑" panose="020B0503020204020204" pitchFamily="34" charset="-122"/>
+              </a:rPr>
+              <a:t>分组决策（哪些层共享 </a:t>
+            </a:r>
+            <a:r>
+              <a:rPr lang="en-US" altLang="zh-CN" dirty="0">
+                <a:latin typeface="微软雅黑" panose="020B0503020204020204" pitchFamily="34" charset="-122"/>
+                <a:ea typeface="微软雅黑" panose="020B0503020204020204" pitchFamily="34" charset="-122"/>
+              </a:rPr>
+              <a:t>block table</a:t>
+            </a:r>
+            <a:r>
+              <a:rPr lang="zh-CN" altLang="en-US" dirty="0">
+                <a:latin typeface="微软雅黑" panose="020B0503020204020204" pitchFamily="34" charset="-122"/>
+                <a:ea typeface="微软雅黑" panose="020B0503020204020204" pitchFamily="34" charset="-122"/>
+              </a:rPr>
+              <a:t>）</a:t>
+            </a:r>
+            <a:endParaRPr lang="en-US" altLang="zh-CN" dirty="0">
+              <a:latin typeface="微软雅黑" panose="020B0503020204020204" pitchFamily="34" charset="-122"/>
+              <a:ea typeface="微软雅黑" panose="020B0503020204020204" pitchFamily="34" charset="-122"/>
+            </a:endParaRPr>
           </a:p>
           <a:p>
             <a:pPr marL="171450" indent="-171450">
@@ -45731,34 +45945,58 @@
               </a:defRPr>
             </a:pPr>
             <a:r>
-              <a:rPr dirty="0" err="1"/>
-              <a:t>算块</a:t>
-            </a:r>
-            <a:r>
-              <a:rPr dirty="0"/>
+              <a:rPr lang="zh-CN" altLang="en-US" dirty="0">
+                <a:latin typeface="微软雅黑" panose="020B0503020204020204" pitchFamily="34" charset="-122"/>
+                <a:ea typeface="微软雅黑" panose="020B0503020204020204" pitchFamily="34" charset="-122"/>
+              </a:rPr>
+              <a:t>算块数</a:t>
+            </a:r>
+            <a:r>
+              <a:rPr lang="en-US" altLang="zh-CN" dirty="0">
+                <a:latin typeface="微软雅黑" panose="020B0503020204020204" pitchFamily="34" charset="-122"/>
+                <a:ea typeface="微软雅黑" panose="020B0503020204020204" pitchFamily="34" charset="-122"/>
+              </a:rPr>
               <a:t>: </a:t>
             </a:r>
             <a:r>
-              <a:rPr dirty="0" err="1"/>
+              <a:rPr lang="en-US" dirty="0" err="1">
+                <a:latin typeface="微软雅黑" panose="020B0503020204020204" pitchFamily="34" charset="-122"/>
+                <a:ea typeface="微软雅黑" panose="020B0503020204020204" pitchFamily="34" charset="-122"/>
+              </a:rPr>
               <a:t>available_memory</a:t>
             </a:r>
             <a:r>
-              <a:rPr dirty="0"/>
+              <a:rPr lang="en-US" dirty="0">
+                <a:latin typeface="微软雅黑" panose="020B0503020204020204" pitchFamily="34" charset="-122"/>
+                <a:ea typeface="微软雅黑" panose="020B0503020204020204" pitchFamily="34" charset="-122"/>
+              </a:rPr>
               <a:t> / </a:t>
             </a:r>
             <a:r>
-              <a:rPr dirty="0" err="1"/>
+              <a:rPr lang="en-US" dirty="0" err="1">
+                <a:latin typeface="微软雅黑" panose="020B0503020204020204" pitchFamily="34" charset="-122"/>
+                <a:ea typeface="微软雅黑" panose="020B0503020204020204" pitchFamily="34" charset="-122"/>
+              </a:rPr>
               <a:t>page_size_bytes</a:t>
             </a:r>
             <a:r>
-              <a:rPr dirty="0"/>
+              <a:rPr lang="en-US" dirty="0">
+                <a:latin typeface="微软雅黑" panose="020B0503020204020204" pitchFamily="34" charset="-122"/>
+                <a:ea typeface="微软雅黑" panose="020B0503020204020204" pitchFamily="34" charset="-122"/>
+              </a:rPr>
               <a:t> → </a:t>
             </a:r>
             <a:r>
-              <a:rPr dirty="0" err="1"/>
+              <a:rPr lang="en-US" dirty="0" err="1">
+                <a:latin typeface="微软雅黑" panose="020B0503020204020204" pitchFamily="34" charset="-122"/>
+                <a:ea typeface="微软雅黑" panose="020B0503020204020204" pitchFamily="34" charset="-122"/>
+              </a:rPr>
               <a:t>num_blocks</a:t>
             </a:r>
-            <a:endParaRPr dirty="0"/>
+            <a:endParaRPr lang="en-US" dirty="0">
+              <a:latin typeface="微软雅黑" panose="020B0503020204020204" pitchFamily="34" charset="-122"/>
+              <a:ea typeface="微软雅黑" panose="020B0503020204020204" pitchFamily="34" charset="-122"/>
+            </a:endParaRPr>
           </a:p>
           <a:p>
             <a:pPr marL="171450" indent="-171450">
@@ -45781,16 +46019,29 @@
               </a:defRPr>
             </a:pPr>
             <a:r>
-              <a:rPr dirty="0" err="1"/>
+              <a:rPr dirty="0" err="1">
+                <a:latin typeface="微软雅黑" panose="020B0503020204020204" pitchFamily="34" charset="-122"/>
+                <a:ea typeface="微软雅黑" panose="020B0503020204020204" pitchFamily="34" charset="-122"/>
+              </a:rPr>
               <a:t>出配置</a:t>
             </a:r>
             <a:r>
-              <a:rPr dirty="0"/>
+              <a:rPr dirty="0">
+                <a:latin typeface="微软雅黑" panose="020B0503020204020204" pitchFamily="34" charset="-122"/>
+                <a:ea typeface="微软雅黑" panose="020B0503020204020204" pitchFamily="34" charset="-122"/>
+              </a:rPr>
               <a:t>: </a:t>
             </a:r>
             <a:r>
-              <a:rPr dirty="0" err="1"/>
-              <a:t>KVCacheConfig</a:t>
+              <a:rPr dirty="0" err="1">
+                <a:latin typeface="微软雅黑" panose="020B0503020204020204" pitchFamily="34" charset="-122"/>
+                <a:ea typeface="微软雅黑" panose="020B0503020204020204" pitchFamily="34" charset="-122"/>
+              </a:rPr>
+              <a:t>KVCa</a:t>
+            </a:r>
+            <a:r>
+              <a:rPr dirty="0" err="1"/>
+              <a:t>cheConfig</a:t>
             </a:r>
             <a:r>
               <a:rPr dirty="0"/>
@@ -45972,8 +46223,8 @@
         </p:nvSpPr>
         <p:spPr>
           <a:xfrm>
-            <a:off x="9174480" y="1590040"/>
-            <a:ext cx="2529840" cy="254000"/>
+            <a:off x="9090659" y="1504188"/>
+            <a:ext cx="2979421" cy="271869"/>
           </a:xfrm>
           <a:prstGeom prst="rect">
             <a:avLst/>
@@ -45999,13 +46250,8 @@
             </a:pPr>
             <a:r>
               <a:rPr dirty="0"/>
-              <a:t>④⑤ Allocate + Reshape: ~60 行，0 </a:t>
-            </a:r>
-            <a:r>
-              <a:rPr dirty="0" err="1"/>
-              <a:t>分支</a:t>
-            </a:r>
-            <a:endParaRPr dirty="0"/>
+              <a:t>④⑤ Allocate + Reshape</a:t>
+            </a:r>
           </a:p>
         </p:txBody>
       </p:sp>
@@ -46023,8 +46269,8 @@
         </p:nvSpPr>
         <p:spPr>
           <a:xfrm>
-            <a:off x="9182100" y="1987199"/>
-            <a:ext cx="2529840" cy="1609095"/>
+            <a:off x="9078660" y="1662482"/>
+            <a:ext cx="2874264" cy="1996252"/>
           </a:xfrm>
           <a:prstGeom prst="rect">
             <a:avLst/>
@@ -46057,32 +46303,36 @@
               </a:defRPr>
             </a:pPr>
             <a:r>
-              <a:rPr dirty="0"/>
-              <a:t>_</a:t>
-            </a:r>
-            <a:r>
-              <a:rPr dirty="0" err="1"/>
-              <a:t>allocate_kv_cache</a:t>
-            </a:r>
-            <a:r>
-              <a:rPr dirty="0"/>
-              <a:t>(): </a:t>
-            </a:r>
-            <a:r>
-              <a:rPr dirty="0" err="1"/>
-              <a:t>torch.zeros</a:t>
-            </a:r>
-            <a:r>
-              <a:rPr dirty="0"/>
-              <a:t>(size, </a:t>
-            </a:r>
-            <a:r>
-              <a:rPr dirty="0" err="1"/>
-              <a:t>dtype</a:t>
-            </a:r>
-            <a:r>
-              <a:rPr dirty="0"/>
-              <a:t>=int8) — 30 行</a:t>
+              <a:rPr lang="en-US" dirty="0"/>
+              <a:t>Allocate: </a:t>
+            </a:r>
+            <a:r>
+              <a:rPr lang="zh-CN" altLang="en-US" dirty="0"/>
+              <a:t>只管总字节数，不管是 </a:t>
+            </a:r>
+            <a:r>
+              <a:rPr lang="en-US" dirty="0"/>
+              <a:t>K </a:t>
+            </a:r>
+            <a:r>
+              <a:rPr lang="zh-CN" altLang="en-US" dirty="0"/>
+              <a:t>是 </a:t>
+            </a:r>
+            <a:r>
+              <a:rPr lang="en-US" dirty="0"/>
+              <a:t>V </a:t>
+            </a:r>
+            <a:r>
+              <a:rPr lang="zh-CN" altLang="en-US" dirty="0"/>
+              <a:t>还是</a:t>
+            </a:r>
+            <a:r>
+              <a:rPr lang="en-US" dirty="0" err="1"/>
+              <a:t>conv_state</a:t>
+            </a:r>
+            <a:r>
+              <a:rPr lang="zh-CN" altLang="en-US" dirty="0"/>
+              <a:t>对分配器来说都一样</a:t>
             </a:r>
           </a:p>
           <a:p>
@@ -46106,32 +46356,32 @@
               </a:defRPr>
             </a:pPr>
             <a:r>
-              <a:rPr dirty="0"/>
-              <a:t>_</a:t>
-            </a:r>
-            <a:r>
-              <a:rPr dirty="0" err="1"/>
-              <a:t>reshape_kv_cache</a:t>
-            </a:r>
-            <a:r>
-              <a:rPr dirty="0"/>
-              <a:t>(): </a:t>
-            </a:r>
-            <a:r>
-              <a:rPr dirty="0" err="1"/>
-              <a:t>raw.view</a:t>
-            </a:r>
-            <a:r>
-              <a:rPr dirty="0"/>
-              <a:t>(</a:t>
-            </a:r>
-            <a:r>
-              <a:rPr dirty="0" err="1"/>
+              <a:rPr lang="en-US" dirty="0"/>
+              <a:t>Reshape: </a:t>
+            </a:r>
+            <a:r>
+              <a:rPr lang="zh-CN" altLang="en-US" dirty="0"/>
+              <a:t>三步机械操作：还原 </a:t>
+            </a:r>
+            <a:r>
+              <a:rPr lang="en-US" dirty="0" err="1"/>
               <a:t>dtype</a:t>
             </a:r>
             <a:r>
-              <a:rPr dirty="0"/>
-              <a:t>).view(shape).permute() — 30 行</a:t>
+              <a:rPr lang="en-US" dirty="0"/>
+              <a:t> → </a:t>
+            </a:r>
+            <a:r>
+              <a:rPr lang="zh-CN" altLang="en-US" dirty="0"/>
+              <a:t>还原 </a:t>
+            </a:r>
+            <a:r>
+              <a:rPr lang="en-US" dirty="0"/>
+              <a:t>shape → </a:t>
+            </a:r>
+            <a:r>
+              <a:rPr lang="zh-CN" altLang="en-US" dirty="0"/>
+              <a:t>调整维度顺序 所有模型类型共用同一套逻辑，零分支</a:t>
             </a:r>
           </a:p>
           <a:p>
@@ -46155,22 +46405,98 @@
               </a:defRPr>
             </a:pPr>
             <a:r>
-              <a:rPr dirty="0"/>
-              <a:t>Mamba/MLA 用 </a:t>
-            </a:r>
-            <a:r>
-              <a:rPr dirty="0" err="1"/>
+              <a:rPr lang="zh-CN" altLang="en-US" dirty="0"/>
+              <a:t>特殊类型</a:t>
+            </a:r>
+            <a:r>
+              <a:rPr lang="en-US" altLang="zh-CN" dirty="0"/>
+              <a:t>:  </a:t>
+            </a:r>
+            <a:r>
+              <a:rPr lang="en-US" dirty="0"/>
+              <a:t>Mamba </a:t>
+            </a:r>
+            <a:r>
+              <a:rPr lang="zh-CN" altLang="en-US" dirty="0"/>
+              <a:t>的 </a:t>
+            </a:r>
+            <a:r>
+              <a:rPr lang="en-US" dirty="0"/>
+              <a:t>conv/</a:t>
+            </a:r>
+            <a:r>
+              <a:rPr lang="en-US" dirty="0" err="1"/>
+              <a:t>ssm</a:t>
+            </a:r>
+            <a:r>
+              <a:rPr lang="en-US" dirty="0"/>
+              <a:t> →</a:t>
+            </a:r>
+            <a:r>
+              <a:rPr lang="en-US" dirty="0" err="1"/>
               <a:t>as_strided</a:t>
             </a:r>
             <a:r>
-              <a:rPr dirty="0"/>
+              <a:rPr lang="en-US" dirty="0"/>
               <a:t> </a:t>
             </a:r>
             <a:r>
-              <a:rPr dirty="0" err="1"/>
-              <a:t>做零拷贝视图</a:t>
-            </a:r>
-            <a:endParaRPr dirty="0"/>
+              <a:rPr lang="zh-CN" altLang="en-US" dirty="0"/>
+              <a:t>拆出多个逻辑视图  </a:t>
+            </a:r>
+            <a:r>
+              <a:rPr lang="en-US" dirty="0"/>
+              <a:t>MLA </a:t>
+            </a:r>
+            <a:r>
+              <a:rPr lang="zh-CN" altLang="en-US" dirty="0"/>
+              <a:t>的 </a:t>
+            </a:r>
+            <a:r>
+              <a:rPr lang="en-US" dirty="0" err="1"/>
+              <a:t>kv_lora</a:t>
+            </a:r>
+            <a:r>
+              <a:rPr lang="en-US" dirty="0"/>
+              <a:t>/</a:t>
+            </a:r>
+            <a:r>
+              <a:rPr lang="en-US" dirty="0" err="1"/>
+              <a:t>k_rope</a:t>
+            </a:r>
+            <a:r>
+              <a:rPr lang="en-US" dirty="0"/>
+              <a:t> → </a:t>
+            </a:r>
+            <a:r>
+              <a:rPr lang="zh-CN" altLang="en-US" dirty="0"/>
+              <a:t>同一 </a:t>
+            </a:r>
+            <a:r>
+              <a:rPr lang="en-US" dirty="0"/>
+              <a:t>tensor </a:t>
+            </a:r>
+            <a:r>
+              <a:rPr lang="zh-CN" altLang="en-US" dirty="0"/>
+              <a:t>内，</a:t>
+            </a:r>
+            <a:r>
+              <a:rPr lang="en-US" dirty="0"/>
+              <a:t>kernel </a:t>
+            </a:r>
+            <a:r>
+              <a:rPr lang="zh-CN" altLang="en-US" dirty="0"/>
+              <a:t>自己 </a:t>
+            </a:r>
+            <a:r>
+              <a:rPr lang="en-US" dirty="0"/>
+              <a:t>offse</a:t>
+            </a:r>
+            <a:r>
+              <a:rPr lang="en-US" altLang="zh-CN" dirty="0"/>
+              <a:t>t</a:t>
+            </a:r>
+            <a:endParaRPr lang="zh-CN" altLang="en-US" dirty="0"/>
           </a:p>
           <a:p>
             <a:pPr>
@@ -46191,38 +46517,53 @@
               </a:defRPr>
             </a:pPr>
             <a:r>
-              <a:rPr dirty="0"/>
+              <a:rPr lang="zh-CN" altLang="en-US" dirty="0"/>
               <a:t>→ </a:t>
             </a:r>
             <a:r>
-              <a:rPr dirty="0" err="1"/>
+              <a:rPr lang="en-US" dirty="0" err="1"/>
               <a:t>model_runner</a:t>
             </a:r>
             <a:r>
-              <a:rPr dirty="0"/>
+              <a:rPr lang="en-US" dirty="0"/>
               <a:t> </a:t>
             </a:r>
             <a:r>
-              <a:rPr dirty="0" err="1"/>
-              <a:t>不关心内部数据怎么分</a:t>
-            </a:r>
-            <a:r>
-              <a:rPr dirty="0"/>
-              <a:t>——</a:t>
-            </a:r>
-            <a:r>
-              <a:rPr dirty="0" err="1"/>
-              <a:t>全由</a:t>
-            </a:r>
-            <a:r>
-              <a:rPr dirty="0"/>
-              <a:t> Backend </a:t>
-            </a:r>
-            <a:r>
-              <a:rPr dirty="0" err="1"/>
-              <a:t>封装</a:t>
-            </a:r>
-            <a:endParaRPr dirty="0"/>
+              <a:rPr lang="zh-CN" altLang="en-US" dirty="0"/>
+              <a:t>从不问</a:t>
+            </a:r>
+            <a:r>
+              <a:rPr lang="en-US" altLang="zh-CN" dirty="0"/>
+              <a:t>“</a:t>
+            </a:r>
+            <a:r>
+              <a:rPr lang="en-US" dirty="0"/>
+              <a:t>buffer </a:t>
+            </a:r>
+            <a:r>
+              <a:rPr lang="zh-CN" altLang="en-US" dirty="0"/>
+              <a:t>里面是什么</a:t>
+            </a:r>
+            <a:r>
+              <a:rPr lang="en-US" altLang="zh-CN" dirty="0"/>
+              <a:t>—</a:t>
+            </a:r>
+            <a:r>
+              <a:rPr lang="en-US" dirty="0"/>
+              <a:t>Backend </a:t>
+            </a:r>
+            <a:r>
+              <a:rPr lang="zh-CN" altLang="en-US" dirty="0"/>
+              <a:t>已经把 </a:t>
+            </a:r>
+            <a:r>
+              <a:rPr lang="en-US" dirty="0"/>
+              <a:t>shape </a:t>
+            </a:r>
+            <a:r>
+              <a:rPr lang="zh-CN" altLang="en-US" dirty="0"/>
+              <a:t>告诉它了</a:t>
+            </a:r>
           </a:p>
         </p:txBody>
       </p:sp>
@@ -46240,7 +46581,7 @@
         </p:nvSpPr>
         <p:spPr>
           <a:xfrm>
-            <a:off x="274320" y="4114800"/>
+            <a:off x="312420" y="4048801"/>
             <a:ext cx="11338560" cy="609600"/>
           </a:xfrm>
           <a:prstGeom prst="roundRect">
@@ -46294,7 +46635,7 @@
         </p:nvSpPr>
         <p:spPr>
           <a:xfrm>
-            <a:off x="274320" y="4114800"/>
+            <a:off x="312420" y="4048801"/>
             <a:ext cx="50800" cy="609600"/>
           </a:xfrm>
           <a:prstGeom prst="rect">
@@ -46344,7 +46685,7 @@
         </p:nvSpPr>
         <p:spPr>
           <a:xfrm>
-            <a:off x="452120" y="4191000"/>
+            <a:off x="490220" y="4125001"/>
             <a:ext cx="10982960" cy="225575"/>
           </a:xfrm>
           <a:prstGeom prst="rect">
@@ -46399,7 +46740,7 @@
         </p:nvSpPr>
         <p:spPr>
           <a:xfrm>
-            <a:off x="452120" y="4394200"/>
+            <a:off x="490220" y="4328201"/>
             <a:ext cx="11160760" cy="220573"/>
           </a:xfrm>
           <a:prstGeom prst="rect">
@@ -46425,7 +46766,80 @@
               </a:defRPr>
             </a:pPr>
             <a:r>
-              <a:t>Backend 是 KV Cache shape 的唯一决定者。每一维的含义、tensor 的数量、K/V 的存储方式，都由 Backend 说了算。model_runner 只做机械执行——拿到 raw tensor → view(dtype) → view(shape) → permute() → 结束。</a:t>
+              <a:rPr dirty="0"/>
+              <a:t>Backend 是 KV Cache shape </a:t>
+            </a:r>
+            <a:r>
+              <a:rPr dirty="0" err="1"/>
+              <a:t>的唯一决定者。每一维的含义、tensor</a:t>
+            </a:r>
+            <a:r>
+              <a:rPr dirty="0"/>
+              <a:t> </a:t>
+            </a:r>
+            <a:r>
+              <a:rPr dirty="0" err="1"/>
+              <a:t>的数量、K</a:t>
+            </a:r>
+            <a:r>
+              <a:rPr dirty="0"/>
+              <a:t>/V </a:t>
+            </a:r>
+            <a:r>
+              <a:rPr dirty="0" err="1"/>
+              <a:t>的存储方式，都由</a:t>
+            </a:r>
+            <a:r>
+              <a:rPr dirty="0"/>
+              <a:t> Backend </a:t>
+            </a:r>
+            <a:r>
+              <a:rPr dirty="0" err="1"/>
+              <a:t>说了算。model_runner</a:t>
+            </a:r>
+            <a:r>
+              <a:rPr dirty="0"/>
+              <a:t> </a:t>
+            </a:r>
+            <a:r>
+              <a:rPr dirty="0" err="1"/>
+              <a:t>只做机械执行</a:t>
+            </a:r>
+            <a:r>
+              <a:rPr dirty="0"/>
+              <a:t>——</a:t>
+            </a:r>
+            <a:r>
+              <a:rPr lang="zh-CN" altLang="en-US" dirty="0"/>
+              <a:t>拿到 </a:t>
+            </a:r>
+            <a:r>
+              <a:rPr lang="en-US" altLang="zh-CN" dirty="0"/>
+              <a:t>Spec → </a:t>
+            </a:r>
+            <a:r>
+              <a:rPr lang="zh-CN" altLang="en-US" dirty="0"/>
+              <a:t>拿到 </a:t>
+            </a:r>
+            <a:r>
+              <a:rPr lang="en-US" altLang="zh-CN" dirty="0"/>
+              <a:t>shape → </a:t>
+            </a:r>
+            <a:r>
+              <a:rPr lang="zh-CN" altLang="en-US" dirty="0"/>
+              <a:t>分配 → </a:t>
+            </a:r>
+            <a:r>
+              <a:rPr lang="en-US" altLang="zh-CN" dirty="0"/>
+              <a:t>reshape → </a:t>
+            </a:r>
+            <a:r>
+              <a:rPr lang="zh-CN" altLang="en-US" dirty="0"/>
+              <a:t>结束</a:t>
+            </a:r>
+            <a:r>
+              <a:rPr dirty="0"/>
+              <a:t>。</a:t>
             </a:r>
           </a:p>
         </p:txBody>
@@ -46548,8 +46962,8 @@
         </p:nvSpPr>
         <p:spPr>
           <a:xfrm>
-            <a:off x="426720" y="4947920"/>
-            <a:ext cx="5181600" cy="254000"/>
+            <a:off x="285242" y="4801031"/>
+            <a:ext cx="5181600" cy="271869"/>
           </a:xfrm>
           <a:prstGeom prst="rect">
             <a:avLst/>
@@ -46574,8 +46988,26 @@
               </a:defRPr>
             </a:pPr>
             <a:r>
-              <a:t>内部数据组织: 单 tensor 内部分拆</a:t>
-            </a:r>
+              <a:rPr dirty="0" err="1"/>
+              <a:t>内部数据组织</a:t>
+            </a:r>
+            <a:r>
+              <a:rPr dirty="0"/>
+              <a:t>: 单 tensor </a:t>
+            </a:r>
+            <a:r>
+              <a:rPr lang="en-US" dirty="0"/>
+              <a:t>,</a:t>
+            </a:r>
+            <a:r>
+              <a:rPr lang="en-US" dirty="0" err="1"/>
+              <a:t>kernel</a:t>
+            </a:r>
+            <a:r>
+              <a:rPr dirty="0" err="1"/>
+              <a:t>内部分拆</a:t>
+            </a:r>
+            <a:endParaRPr dirty="0"/>
           </a:p>
         </p:txBody>
       </p:sp>
@@ -46593,8 +47025,8 @@
         </p:nvSpPr>
         <p:spPr>
           <a:xfrm>
-            <a:off x="426720" y="5227320"/>
-            <a:ext cx="5334000" cy="839653"/>
+            <a:off x="360045" y="4958215"/>
+            <a:ext cx="5353050" cy="1226811"/>
           </a:xfrm>
           <a:prstGeom prst="rect">
             <a:avLst/>
@@ -46625,22 +47057,13 @@
               </a:defRPr>
             </a:pPr>
             <a:r>
-              <a:rPr dirty="0"/>
-              <a:t>GQA: tensor[0]=K, tensor[1]=V — kernel </a:t>
-            </a:r>
-            <a:r>
-              <a:rPr dirty="0" err="1"/>
-              <a:t>通过</a:t>
-            </a:r>
-            <a:r>
-              <a:rPr dirty="0"/>
-              <a:t> offset </a:t>
-            </a:r>
-            <a:r>
-              <a:rPr dirty="0" err="1"/>
-              <a:t>区分</a:t>
-            </a:r>
-            <a:endParaRPr dirty="0"/>
+              <a:rPr lang="zh-CN" altLang="en-US" dirty="0"/>
+              <a:t>所有模型类型共用一条原则</a:t>
+            </a:r>
+            <a:r>
+              <a:rPr lang="en-US" altLang="zh-CN" dirty="0"/>
+              <a:t>:</a:t>
+            </a:r>
           </a:p>
           <a:p>
             <a:pPr>
@@ -46661,22 +47084,129 @@
               </a:defRPr>
             </a:pPr>
             <a:r>
-              <a:rPr dirty="0"/>
-              <a:t>MLA: tensor[:,:,:512]=</a:t>
-            </a:r>
-            <a:r>
-              <a:rPr dirty="0" err="1"/>
+              <a:rPr lang="en-US" altLang="zh-CN" dirty="0"/>
+              <a:t>  → </a:t>
+            </a:r>
+            <a:r>
+              <a:rPr lang="zh-CN" altLang="en-US" dirty="0"/>
+              <a:t>一个 </a:t>
+            </a:r>
+            <a:r>
+              <a:rPr lang="en-US" dirty="0"/>
+              <a:t>layer </a:t>
+            </a:r>
+            <a:r>
+              <a:rPr lang="zh-CN" altLang="en-US" dirty="0"/>
+              <a:t>一个 </a:t>
+            </a:r>
+            <a:r>
+              <a:rPr lang="en-US" dirty="0"/>
+              <a:t>tensor，</a:t>
+            </a:r>
+            <a:r>
+              <a:rPr lang="zh-CN" altLang="en-US" dirty="0"/>
+              <a:t>不同类型的组件打包在同一块 </a:t>
+            </a:r>
+            <a:r>
+              <a:rPr lang="en-US" dirty="0"/>
+              <a:t>buffer </a:t>
+            </a:r>
+            <a:r>
+              <a:rPr lang="zh-CN" altLang="en-US" dirty="0"/>
+              <a:t>里→ </a:t>
+            </a:r>
+            <a:r>
+              <a:rPr lang="en-US" dirty="0"/>
+              <a:t>GQA </a:t>
+            </a:r>
+            <a:r>
+              <a:rPr lang="zh-CN" altLang="en-US" dirty="0"/>
+              <a:t>的 </a:t>
+            </a:r>
+            <a:r>
+              <a:rPr lang="en-US" dirty="0"/>
+              <a:t>K </a:t>
+            </a:r>
+            <a:r>
+              <a:rPr lang="zh-CN" altLang="en-US" dirty="0"/>
+              <a:t>和 </a:t>
+            </a:r>
+            <a:r>
+              <a:rPr lang="en-US" dirty="0"/>
+              <a:t>V </a:t>
+            </a:r>
+            <a:r>
+              <a:rPr lang="zh-CN" altLang="en-US" dirty="0"/>
+              <a:t>在同一个 </a:t>
+            </a:r>
+            <a:r>
+              <a:rPr lang="en-US" dirty="0"/>
+              <a:t>tensor </a:t>
+            </a:r>
+            <a:r>
+              <a:rPr lang="zh-CN" altLang="en-US" dirty="0"/>
+              <a:t>的相邻区域 → </a:t>
+            </a:r>
+            <a:r>
+              <a:rPr lang="en-US" dirty="0"/>
+              <a:t>MLA </a:t>
+            </a:r>
+            <a:r>
+              <a:rPr lang="zh-CN" altLang="en-US" dirty="0"/>
+              <a:t>的 </a:t>
+            </a:r>
+            <a:r>
+              <a:rPr lang="en-US" dirty="0" err="1"/>
               <a:t>kv_lora</a:t>
             </a:r>
             <a:r>
-              <a:rPr dirty="0"/>
-              <a:t>, tensor[:,:,512:]=</a:t>
-            </a:r>
-            <a:r>
-              <a:rPr dirty="0" err="1"/>
+              <a:rPr lang="en-US" dirty="0"/>
+              <a:t> </a:t>
+            </a:r>
+            <a:r>
+              <a:rPr lang="zh-CN" altLang="en-US" dirty="0"/>
+              <a:t>和 </a:t>
+            </a:r>
+            <a:r>
+              <a:rPr lang="en-US" dirty="0" err="1"/>
               <a:t>k_rope</a:t>
             </a:r>
-            <a:endParaRPr dirty="0"/>
+            <a:r>
+              <a:rPr lang="en-US" dirty="0"/>
+              <a:t> </a:t>
+            </a:r>
+            <a:r>
+              <a:rPr lang="zh-CN" altLang="en-US" dirty="0"/>
+              <a:t>在同一 </a:t>
+            </a:r>
+            <a:r>
+              <a:rPr lang="en-US" dirty="0"/>
+              <a:t>tensor </a:t>
+            </a:r>
+            <a:r>
+              <a:rPr lang="zh-CN" altLang="en-US" dirty="0"/>
+              <a:t>的相邻区域 → </a:t>
+            </a:r>
+            <a:r>
+              <a:rPr lang="en-US" dirty="0"/>
+              <a:t>fp8 </a:t>
+            </a:r>
+            <a:r>
+              <a:rPr lang="zh-CN" altLang="en-US" dirty="0"/>
+              <a:t>的就多几个 </a:t>
+            </a:r>
+            <a:r>
+              <a:rPr lang="en-US" dirty="0"/>
+              <a:t>padding </a:t>
+            </a:r>
+            <a:r>
+              <a:rPr lang="zh-CN" altLang="en-US" dirty="0"/>
+              <a:t>字节，还是同一个 </a:t>
+            </a:r>
+            <a:r>
+              <a:rPr lang="en-US" dirty="0"/>
+              <a:t>tensor</a:t>
+            </a:r>
           </a:p>
           <a:p>
             <a:pPr>
@@ -46697,16 +47227,36 @@
               </a:defRPr>
             </a:pPr>
             <a:r>
-              <a:rPr dirty="0"/>
-              <a:t>MLA fp8: 单 tensor, </a:t>
-            </a:r>
-            <a:r>
-              <a:rPr dirty="0" err="1"/>
-              <a:t>字节级自定义布局</a:t>
-            </a:r>
-            <a:r>
-              <a:rPr dirty="0"/>
-              <a:t> (656B/token V3.2)</a:t>
+              <a:rPr lang="en-US" dirty="0"/>
+              <a:t>kernel </a:t>
+            </a:r>
+            <a:r>
+              <a:rPr lang="zh-CN" altLang="en-US" dirty="0"/>
+              <a:t>负责拆</a:t>
+            </a:r>
+            <a:r>
+              <a:rPr lang="en-US" altLang="zh-CN" dirty="0"/>
+              <a:t>:  </a:t>
+            </a:r>
+            <a:r>
+              <a:rPr lang="zh-CN" altLang="en-US" dirty="0"/>
+              <a:t>传入一个 </a:t>
+            </a:r>
+            <a:r>
+              <a:rPr lang="en-US" dirty="0"/>
+              <a:t>int8 blob → kernel </a:t>
+            </a:r>
+            <a:r>
+              <a:rPr lang="zh-CN" altLang="en-US" dirty="0"/>
+              <a:t>内部按 </a:t>
+            </a:r>
+            <a:r>
+              <a:rPr lang="en-US" dirty="0"/>
+              <a:t>struct </a:t>
+            </a:r>
+            <a:r>
+              <a:rPr lang="zh-CN" altLang="en-US" dirty="0"/>
+              <a:t>布局解析各字段</a:t>
             </a:r>
           </a:p>
           <a:p>
@@ -46728,24 +47278,36 @@
               </a:defRPr>
             </a:pPr>
             <a:r>
-              <a:rPr dirty="0"/>
-              <a:t>→ </a:t>
-            </a:r>
-            <a:r>
-              <a:rPr b="1" dirty="0"/>
-              <a:t>kernel </a:t>
-            </a:r>
-            <a:r>
-              <a:rPr b="1" dirty="0" err="1"/>
-              <a:t>内部解析，host</a:t>
-            </a:r>
-            <a:r>
-              <a:rPr b="1" dirty="0"/>
-              <a:t> </a:t>
-            </a:r>
-            <a:r>
-              <a:rPr b="1" dirty="0" err="1"/>
-              <a:t>侧完全不需要知道内部结构</a:t>
+              <a:rPr lang="en-US" dirty="0"/>
+              <a:t>host </a:t>
+            </a:r>
+            <a:r>
+              <a:rPr lang="zh-CN" altLang="en-US" dirty="0"/>
+              <a:t>只管传</a:t>
+            </a:r>
+            <a:r>
+              <a:rPr lang="en-US" altLang="zh-CN" dirty="0"/>
+              <a:t>:    </a:t>
+            </a:r>
+            <a:r>
+              <a:rPr lang="en-US" dirty="0" err="1"/>
+              <a:t>raw.view</a:t>
+            </a:r>
+            <a:r>
+              <a:rPr lang="en-US" dirty="0"/>
+              <a:t>(</a:t>
+            </a:r>
+            <a:r>
+              <a:rPr lang="en-US" dirty="0" err="1"/>
+              <a:t>dtype</a:t>
+            </a:r>
+            <a:r>
+              <a:rPr lang="en-US" dirty="0"/>
+              <a:t>).view(shape) → </a:t>
+            </a:r>
+            <a:r>
+              <a:rPr lang="zh-CN" altLang="en-US" dirty="0"/>
+              <a:t>传进去 → 结束</a:t>
             </a:r>
             <a:endParaRPr b="1" dirty="0"/>
           </a:p>
@@ -46869,7 +47431,7 @@
         </p:nvSpPr>
         <p:spPr>
           <a:xfrm>
-            <a:off x="6187440" y="4947920"/>
+            <a:off x="6187440" y="4864743"/>
             <a:ext cx="5273040" cy="254000"/>
           </a:xfrm>
           <a:prstGeom prst="rect">
@@ -46932,7 +47494,7 @@
         </p:nvSpPr>
         <p:spPr>
           <a:xfrm>
-            <a:off x="6187440" y="5227320"/>
+            <a:off x="6206490" y="5137166"/>
             <a:ext cx="5273040" cy="797560"/>
           </a:xfrm>
           <a:prstGeom prst="rect">
@@ -49113,7 +49675,84 @@
               </a:defRPr>
             </a:pPr>
             <a:r>
-              <a:t>上游 Backend 的 get_kv_cache_shape() 一个方法回答了全部存储问题；Ascend Backend 的同名方法只回答了 1/N 的信息 (一个 tensor 的 shape)，剩下 N-1/N 泄漏到了 model_runner 的 15+ 个 if-else 分支里。</a:t>
+              <a:rPr dirty="0" err="1"/>
+              <a:t>上游</a:t>
+            </a:r>
+            <a:r>
+              <a:rPr dirty="0"/>
+              <a:t> Backend 的 </a:t>
+            </a:r>
+            <a:r>
+              <a:rPr dirty="0" err="1"/>
+              <a:t>get_kv_cache_shape</a:t>
+            </a:r>
+            <a:r>
+              <a:rPr dirty="0"/>
+              <a:t>() </a:t>
+            </a:r>
+            <a:r>
+              <a:rPr dirty="0" err="1"/>
+              <a:t>一个方法回答了全部存储问题；Ascend</a:t>
+            </a:r>
+            <a:r>
+              <a:rPr dirty="0"/>
+              <a:t> Backend </a:t>
+            </a:r>
+            <a:r>
+              <a:rPr dirty="0" err="1"/>
+              <a:t>的同名方法只回答了</a:t>
+            </a:r>
+            <a:r>
+              <a:rPr dirty="0"/>
+              <a:t> 1/N </a:t>
+            </a:r>
+            <a:r>
+              <a:rPr dirty="0" err="1"/>
+              <a:t>的信息</a:t>
+            </a:r>
+            <a:r>
+              <a:rPr dirty="0"/>
+              <a:t> (</a:t>
+            </a:r>
+            <a:r>
+              <a:rPr dirty="0" err="1"/>
+              <a:t>一个</a:t>
+            </a:r>
+            <a:r>
+              <a:rPr dirty="0"/>
+              <a:t> tensor 的 shape)，</a:t>
+            </a:r>
+            <a:r>
+              <a:rPr dirty="0" err="1"/>
+              <a:t>剩下</a:t>
+            </a:r>
+            <a:r>
+              <a:rPr dirty="0"/>
+              <a:t> N-1/N </a:t>
+            </a:r>
+            <a:r>
+              <a:rPr dirty="0" err="1"/>
+              <a:t>泄漏到了</a:t>
+            </a:r>
+            <a:r>
+              <a:rPr dirty="0"/>
+              <a:t> </a:t>
+            </a:r>
+            <a:r>
+              <a:rPr dirty="0" err="1"/>
+              <a:t>model_runner</a:t>
+            </a:r>
+            <a:r>
+              <a:rPr dirty="0"/>
+              <a:t> 的 15+ 个 if-else </a:t>
+            </a:r>
+            <a:r>
+              <a:rPr dirty="0" err="1"/>
+              <a:t>分支里</a:t>
+            </a:r>
+            <a:r>
+              <a:rPr dirty="0"/>
+              <a:t>。</a:t>
             </a:r>
           </a:p>
         </p:txBody>
@@ -57995,83 +58634,37 @@
 </file>
 
 <file path=ppt/slides/slide9.xml><?xml version="1.0" encoding="utf-8"?>
-<p:sld xmlns:a="http://schemas.openxmlformats.org/drawingml/2006/main" xmlns:p="http://schemas.openxmlformats.org/presentationml/2006/main" xmlns:r="http://schemas.openxmlformats.org/officeDocument/2006/relationships">
+<p:sld xmlns:a="http://schemas.openxmlformats.org/drawingml/2006/main" xmlns:r="http://schemas.openxmlformats.org/officeDocument/2006/relationships" xmlns:p="http://schemas.openxmlformats.org/presentationml/2006/main">
   <p:cSld>
-    <p:bg>
-      <p:bgPr>
-        <a:solidFill>
-          <a:srgbClr val="FFFFFF"/>
-        </a:solidFill>
-        <a:effectLst/>
-      </p:bgPr>
-    </p:bg>
     <p:spTree>
       <p:nvGrpSpPr>
         <p:cNvPr id="1" name=""/>
         <p:cNvGrpSpPr/>
         <p:nvPr/>
       </p:nvGrpSpPr>
-      <p:grpSpPr/>
+      <p:grpSpPr>
+        <a:xfrm>
+          <a:off x="0" y="0"/>
+          <a:ext cx="0" cy="0"/>
+          <a:chOff x="0" y="0"/>
+          <a:chExt cx="0" cy="0"/>
+        </a:xfrm>
+      </p:grpSpPr>
       <p:sp>
         <p:nvSpPr>
-          <p:cNvPr id="2" name="Title 1"/>
-          <p:cNvSpPr>
-            <a:spLocks noGrp="1"/>
-          </p:cNvSpPr>
-          <p:nvPr>
-            <p:ph type="ctrTitle"/>
-          </p:nvPr>
-        </p:nvSpPr>
-        <p:spPr/>
-        <p:txBody>
-          <a:bodyPr/>
-          <a:lstStyle/>
-          <a:p/>
-        </p:txBody>
-      </p:sp>
-      <p:sp>
-        <p:nvSpPr>
-          <p:cNvPr id="3" name="Text Placeholder 2"/>
-          <p:cNvSpPr>
-            <a:spLocks noGrp="1"/>
-          </p:cNvSpPr>
-          <p:nvPr>
-            <p:ph type="body" idx="10" sz="quarter"/>
-          </p:nvPr>
-        </p:nvSpPr>
-        <p:spPr/>
-        <p:txBody>
-          <a:bodyPr/>
-          <a:lstStyle/>
-          <a:p/>
-        </p:txBody>
-      </p:sp>
-      <p:sp>
-        <p:nvSpPr>
-          <p:cNvPr id="4" name="Text Placeholder 3"/>
-          <p:cNvSpPr>
-            <a:spLocks noGrp="1"/>
-          </p:cNvSpPr>
-          <p:nvPr>
-            <p:ph type="body" idx="11" sz="quarter"/>
-          </p:nvPr>
-        </p:nvSpPr>
-        <p:spPr/>
-        <p:txBody>
-          <a:bodyPr/>
-          <a:lstStyle/>
-          <a:p/>
-        </p:txBody>
-      </p:sp>
-      <p:sp>
-        <p:nvSpPr>
-          <p:cNvPr id="5" name="TextBox 4"/>
+          <p:cNvPr id="2" name="TextBox 4">
+            <a:extLst>
+              <a:ext uri="{FF2B5EF4-FFF2-40B4-BE49-F238E27FC236}">
+                <a16:creationId xmlns:a16="http://schemas.microsoft.com/office/drawing/2014/main" id="{F7ABA423-353A-6F39-CA96-7DAABEB46FB3}"/>
+              </a:ext>
+            </a:extLst>
+          </p:cNvPr>
           <p:cNvSpPr txBox="1"/>
           <p:nvPr/>
         </p:nvSpPr>
         <p:spPr>
           <a:xfrm>
-            <a:off x="548640" y="2011680"/>
+            <a:off x="426720" y="493776"/>
             <a:ext cx="10972800" cy="640080"/>
           </a:xfrm>
           <a:prstGeom prst="rect">
@@ -58101,49 +58694,19 @@
       </p:sp>
       <p:sp>
         <p:nvSpPr>
-          <p:cNvPr id="6" name="TextBox 5"/>
-          <p:cNvSpPr txBox="1"/>
-          <p:nvPr/>
-        </p:nvSpPr>
-        <p:spPr>
-          <a:xfrm>
-            <a:off x="548640" y="2651760"/>
-            <a:ext cx="10972800" cy="365760"/>
-          </a:xfrm>
-          <a:prstGeom prst="rect">
-            <a:avLst/>
-          </a:prstGeom>
-          <a:noFill/>
-        </p:spPr>
-        <p:txBody>
-          <a:bodyPr wrap="square">
-            <a:spAutoFit/>
-          </a:bodyPr>
-          <a:lstStyle/>
-          <a:p>
-            <a:pPr algn="ctr">
-              <a:defRPr sz="1100" b="0">
-                <a:solidFill>
-                  <a:srgbClr val="595757"/>
-                </a:solidFill>
-                <a:latin typeface="Microsoft YaHei"/>
-              </a:defRPr>
-            </a:pPr>
-            <a:r>
-              <a:t>记住这三条原则，就能理解为什么 Ascend 的差异不是"实现细节不同"，而是"设计原则层面的偏离"</a:t>
-            </a:r>
-          </a:p>
-        </p:txBody>
-      </p:sp>
-      <p:sp>
-        <p:nvSpPr>
-          <p:cNvPr id="7" name="Rounded Rectangle 6"/>
+          <p:cNvPr id="30" name="Rounded Rectangle 10">
+            <a:extLst>
+              <a:ext uri="{FF2B5EF4-FFF2-40B4-BE49-F238E27FC236}">
+                <a16:creationId xmlns:a16="http://schemas.microsoft.com/office/drawing/2014/main" id="{0FBB3AB0-E434-AC3A-B32A-3E46A9C8C96D}"/>
+              </a:ext>
+            </a:extLst>
+          </p:cNvPr>
           <p:cNvSpPr/>
           <p:nvPr/>
         </p:nvSpPr>
         <p:spPr>
           <a:xfrm>
-            <a:off x="274320" y="3200400"/>
+            <a:off x="4084320" y="1682496"/>
             <a:ext cx="3657600" cy="3200400"/>
           </a:xfrm>
           <a:prstGeom prst="roundRect">
@@ -58179,25 +58742,32 @@
           <a:lstStyle/>
           <a:p>
             <a:pPr algn="ctr"/>
+            <a:endParaRPr/>
           </a:p>
         </p:txBody>
       </p:sp>
       <p:sp>
         <p:nvSpPr>
-          <p:cNvPr id="8" name="Rectangle 7"/>
+          <p:cNvPr id="31" name="Rectangle 11">
+            <a:extLst>
+              <a:ext uri="{FF2B5EF4-FFF2-40B4-BE49-F238E27FC236}">
+                <a16:creationId xmlns:a16="http://schemas.microsoft.com/office/drawing/2014/main" id="{685805D1-AD76-BFDE-F1B0-BDFD1980DF27}"/>
+              </a:ext>
+            </a:extLst>
+          </p:cNvPr>
           <p:cNvSpPr/>
           <p:nvPr/>
         </p:nvSpPr>
         <p:spPr>
           <a:xfrm>
-            <a:off x="274320" y="3200400"/>
+            <a:off x="4084320" y="1682496"/>
             <a:ext cx="38100" cy="3200400"/>
           </a:xfrm>
           <a:prstGeom prst="rect">
             <a:avLst/>
           </a:prstGeom>
           <a:solidFill>
-            <a:srgbClr val="58B230"/>
+            <a:srgbClr val="ED6C00"/>
           </a:solidFill>
           <a:ln>
             <a:noFill/>
@@ -58222,18 +58792,25 @@
           <a:lstStyle/>
           <a:p>
             <a:pPr algn="ctr"/>
+            <a:endParaRPr/>
           </a:p>
         </p:txBody>
       </p:sp>
       <p:sp>
         <p:nvSpPr>
-          <p:cNvPr id="9" name="TextBox 8"/>
+          <p:cNvPr id="32" name="TextBox 12">
+            <a:extLst>
+              <a:ext uri="{FF2B5EF4-FFF2-40B4-BE49-F238E27FC236}">
+                <a16:creationId xmlns:a16="http://schemas.microsoft.com/office/drawing/2014/main" id="{0D4B2195-7044-3D69-7416-30EA30B22881}"/>
+              </a:ext>
+            </a:extLst>
+          </p:cNvPr>
           <p:cNvSpPr txBox="1"/>
           <p:nvPr/>
         </p:nvSpPr>
         <p:spPr>
           <a:xfrm>
-            <a:off x="426720" y="3302000"/>
+            <a:off x="4236720" y="1784096"/>
             <a:ext cx="3352800" cy="279400"/>
           </a:xfrm>
           <a:prstGeom prst="rect">
@@ -58250,26 +58827,32 @@
             <a:pPr algn="l">
               <a:defRPr sz="1400" b="1">
                 <a:solidFill>
-                  <a:srgbClr val="58B230"/>
+                  <a:srgbClr val="ED6C00"/>
                 </a:solidFill>
                 <a:latin typeface="Microsoft YaHei"/>
               </a:defRPr>
             </a:pPr>
             <a:r>
-              <a:t>原则 1: Backend 说了算</a:t>
+              <a:t>原则 2: 单 Tensor 原则</a:t>
             </a:r>
           </a:p>
         </p:txBody>
       </p:sp>
       <p:sp>
         <p:nvSpPr>
-          <p:cNvPr id="10" name="TextBox 9"/>
+          <p:cNvPr id="33" name="TextBox 13">
+            <a:extLst>
+              <a:ext uri="{FF2B5EF4-FFF2-40B4-BE49-F238E27FC236}">
+                <a16:creationId xmlns:a16="http://schemas.microsoft.com/office/drawing/2014/main" id="{48999EEA-C568-1AEC-680A-F1D8AACB6DC5}"/>
+              </a:ext>
+            </a:extLst>
+          </p:cNvPr>
           <p:cNvSpPr txBox="1"/>
           <p:nvPr/>
         </p:nvSpPr>
         <p:spPr>
           <a:xfrm>
-            <a:off x="426720" y="3632200"/>
+            <a:off x="4236720" y="2114296"/>
             <a:ext cx="3352800" cy="2667000"/>
           </a:xfrm>
           <a:prstGeom prst="rect">
@@ -58295,7 +58878,7 @@
               </a:defRPr>
             </a:pPr>
             <a:r>
-              <a:t>KV Cache shape 的唯一决定者是 Backend</a:t>
+              <a:t>所有模型类型都产生 1 个 tensor/层</a:t>
             </a:r>
           </a:p>
           <a:p>
@@ -58311,7 +58894,7 @@
               </a:defRPr>
             </a:pPr>
             <a:r>
-              <a:t>get_kv_cache_shape() 返回完整可用 shape</a:t>
+              <a:t>（或 1 个 buffer + as_strided views）</a:t>
             </a:r>
           </a:p>
           <a:p>
@@ -58327,7 +58910,7 @@
               </a:defRPr>
             </a:pPr>
             <a:r>
-              <a:t>每一维的含义、tensor 的数量、K/V 的存储方式</a:t>
+              <a:t>MLA: kv_lora + k_rope 同一 tensor，kernel 内 offset</a:t>
             </a:r>
           </a:p>
           <a:p>
@@ -58343,7 +58926,7 @@
               </a:defRPr>
             </a:pPr>
             <a:r>
-              <a:t>——都由 Backend 封装</a:t>
+              <a:t>Mamba: 1 buffer → N 个 as_strided 零拷贝视图</a:t>
             </a:r>
           </a:p>
           <a:p>
@@ -58359,20 +58942,26 @@
               </a:defRPr>
             </a:pPr>
             <a:r>
-              <a:t>→ model_runner 不关心内部怎么拆分</a:t>
+              <a:t>→ Host 侧只管分配，不关心内部数据组织</a:t>
             </a:r>
           </a:p>
         </p:txBody>
       </p:sp>
       <p:sp>
         <p:nvSpPr>
-          <p:cNvPr id="11" name="Rounded Rectangle 10"/>
+          <p:cNvPr id="34" name="Rounded Rectangle 14">
+            <a:extLst>
+              <a:ext uri="{FF2B5EF4-FFF2-40B4-BE49-F238E27FC236}">
+                <a16:creationId xmlns:a16="http://schemas.microsoft.com/office/drawing/2014/main" id="{71B87FD4-FB0D-8536-D97C-93101BF4D1C1}"/>
+              </a:ext>
+            </a:extLst>
+          </p:cNvPr>
           <p:cNvSpPr/>
           <p:nvPr/>
         </p:nvSpPr>
         <p:spPr>
           <a:xfrm>
-            <a:off x="4206240" y="3200400"/>
+            <a:off x="8016240" y="1682496"/>
             <a:ext cx="3657600" cy="3200400"/>
           </a:xfrm>
           <a:prstGeom prst="roundRect">
@@ -58408,25 +58997,32 @@
           <a:lstStyle/>
           <a:p>
             <a:pPr algn="ctr"/>
+            <a:endParaRPr/>
           </a:p>
         </p:txBody>
       </p:sp>
       <p:sp>
         <p:nvSpPr>
-          <p:cNvPr id="12" name="Rectangle 11"/>
+          <p:cNvPr id="35" name="Rectangle 15">
+            <a:extLst>
+              <a:ext uri="{FF2B5EF4-FFF2-40B4-BE49-F238E27FC236}">
+                <a16:creationId xmlns:a16="http://schemas.microsoft.com/office/drawing/2014/main" id="{2081FE38-7E01-0405-73E6-D45DF6FE1D7F}"/>
+              </a:ext>
+            </a:extLst>
+          </p:cNvPr>
           <p:cNvSpPr/>
           <p:nvPr/>
         </p:nvSpPr>
         <p:spPr>
           <a:xfrm>
-            <a:off x="4206240" y="3200400"/>
+            <a:off x="8016240" y="1682496"/>
             <a:ext cx="38100" cy="3200400"/>
           </a:xfrm>
           <a:prstGeom prst="rect">
             <a:avLst/>
           </a:prstGeom>
           <a:solidFill>
-            <a:srgbClr val="ED6C00"/>
+            <a:srgbClr val="C8102E"/>
           </a:solidFill>
           <a:ln>
             <a:noFill/>
@@ -58451,18 +59047,25 @@
           <a:lstStyle/>
           <a:p>
             <a:pPr algn="ctr"/>
+            <a:endParaRPr/>
           </a:p>
         </p:txBody>
       </p:sp>
       <p:sp>
         <p:nvSpPr>
-          <p:cNvPr id="13" name="TextBox 12"/>
+          <p:cNvPr id="36" name="TextBox 16">
+            <a:extLst>
+              <a:ext uri="{FF2B5EF4-FFF2-40B4-BE49-F238E27FC236}">
+                <a16:creationId xmlns:a16="http://schemas.microsoft.com/office/drawing/2014/main" id="{3FA75DB4-2840-B996-49D4-B02AA0DD4138}"/>
+              </a:ext>
+            </a:extLst>
+          </p:cNvPr>
           <p:cNvSpPr txBox="1"/>
           <p:nvPr/>
         </p:nvSpPr>
         <p:spPr>
           <a:xfrm>
-            <a:off x="4358640" y="3302000"/>
+            <a:off x="8168640" y="1784096"/>
             <a:ext cx="3352800" cy="279400"/>
           </a:xfrm>
           <a:prstGeom prst="rect">
@@ -58479,26 +59082,32 @@
             <a:pPr algn="l">
               <a:defRPr sz="1400" b="1">
                 <a:solidFill>
-                  <a:srgbClr val="ED6C00"/>
+                  <a:srgbClr val="C8102E"/>
                 </a:solidFill>
                 <a:latin typeface="Microsoft YaHei"/>
               </a:defRPr>
             </a:pPr>
             <a:r>
-              <a:t>原则 2: 单 Tensor 原则</a:t>
+              <a:t>原则 3: model_runner 零感知</a:t>
             </a:r>
           </a:p>
         </p:txBody>
       </p:sp>
       <p:sp>
         <p:nvSpPr>
-          <p:cNvPr id="14" name="TextBox 13"/>
+          <p:cNvPr id="37" name="TextBox 17">
+            <a:extLst>
+              <a:ext uri="{FF2B5EF4-FFF2-40B4-BE49-F238E27FC236}">
+                <a16:creationId xmlns:a16="http://schemas.microsoft.com/office/drawing/2014/main" id="{AA30F7B6-87C7-E6AB-FB4E-0B1F6BD81E5E}"/>
+              </a:ext>
+            </a:extLst>
+          </p:cNvPr>
           <p:cNvSpPr txBox="1"/>
           <p:nvPr/>
         </p:nvSpPr>
         <p:spPr>
           <a:xfrm>
-            <a:off x="4358640" y="3632200"/>
+            <a:off x="8168640" y="2114296"/>
             <a:ext cx="3352800" cy="2667000"/>
           </a:xfrm>
           <a:prstGeom prst="rect">
@@ -58524,7 +59133,7 @@
               </a:defRPr>
             </a:pPr>
             <a:r>
-              <a:t>所有模型类型都产生 1 个 tensor/层</a:t>
+              <a:t>model_runner 不检查 layer_type</a:t>
             </a:r>
           </a:p>
           <a:p>
@@ -58540,7 +59149,7 @@
               </a:defRPr>
             </a:pPr>
             <a:r>
-              <a:t>（或 1 个 buffer + as_strided views）</a:t>
+              <a:t>不判断 use_sparse / use_compress / C8 / A5 / A3</a:t>
             </a:r>
           </a:p>
           <a:p>
@@ -58556,7 +59165,7 @@
               </a:defRPr>
             </a:pPr>
             <a:r>
-              <a:t>MLA: kv_lora + k_rope 同一 tensor，kernel 内 offset</a:t>
+              <a:t>拿到 Spec → 拿到 shape → 分配 → reshape → 结束</a:t>
             </a:r>
           </a:p>
           <a:p>
@@ -58572,7 +59181,7 @@
               </a:defRPr>
             </a:pPr>
             <a:r>
-              <a:t>Mamba: 1 buffer → N 个 as_strided 零拷贝视图</a:t>
+              <a:t>→ 所有模型特有逻辑封装在 Spec 子类 + Backend 内</a:t>
             </a:r>
           </a:p>
           <a:p>
@@ -58588,20 +59197,82 @@
               </a:defRPr>
             </a:pPr>
             <a:r>
-              <a:t>→ Host 侧只管分配，不关心内部数据组织</a:t>
+              <a:t>→ ~60 行代码，0 分支，新增模型不改 model_runner</a:t>
             </a:r>
           </a:p>
         </p:txBody>
       </p:sp>
       <p:sp>
         <p:nvSpPr>
-          <p:cNvPr id="15" name="Rounded Rectangle 14"/>
+          <p:cNvPr id="38" name="TextBox 18">
+            <a:extLst>
+              <a:ext uri="{FF2B5EF4-FFF2-40B4-BE49-F238E27FC236}">
+                <a16:creationId xmlns:a16="http://schemas.microsoft.com/office/drawing/2014/main" id="{A0C5C6D6-22A5-74F7-3287-8F20C0EA2F07}"/>
+              </a:ext>
+            </a:extLst>
+          </p:cNvPr>
+          <p:cNvSpPr txBox="1"/>
+          <p:nvPr/>
+        </p:nvSpPr>
+        <p:spPr>
+          <a:xfrm>
+            <a:off x="548640" y="5294376"/>
+            <a:ext cx="10972800" cy="274320"/>
+          </a:xfrm>
+          <a:prstGeom prst="rect">
+            <a:avLst/>
+          </a:prstGeom>
+          <a:noFill/>
+        </p:spPr>
+        <p:txBody>
+          <a:bodyPr wrap="square">
+            <a:spAutoFit/>
+          </a:bodyPr>
+          <a:lstStyle/>
+          <a:p>
+            <a:pPr algn="ctr">
+              <a:defRPr sz="1100" b="1">
+                <a:solidFill>
+                  <a:srgbClr val="C8102E"/>
+                </a:solidFill>
+                <a:latin typeface="Microsoft YaHei"/>
+              </a:defRPr>
+            </a:pPr>
+            <a:r>
+              <a:rPr dirty="0"/>
+              <a:t>➜ </a:t>
+            </a:r>
+            <a:r>
+              <a:rPr dirty="0" err="1"/>
+              <a:t>接下来我们将逐层对比</a:t>
+            </a:r>
+            <a:r>
+              <a:rPr dirty="0"/>
+              <a:t> Ascend </a:t>
+            </a:r>
+            <a:r>
+              <a:rPr dirty="0" err="1"/>
+              <a:t>的实现，看看在每一层上，这三条原则是如何被打破的</a:t>
+            </a:r>
+            <a:endParaRPr dirty="0"/>
+          </a:p>
+        </p:txBody>
+      </p:sp>
+      <p:sp>
+        <p:nvSpPr>
+          <p:cNvPr id="39" name="Rounded Rectangle 6">
+            <a:extLst>
+              <a:ext uri="{FF2B5EF4-FFF2-40B4-BE49-F238E27FC236}">
+                <a16:creationId xmlns:a16="http://schemas.microsoft.com/office/drawing/2014/main" id="{C41590A0-16FC-3329-C9C1-5170E1C74FB7}"/>
+              </a:ext>
+            </a:extLst>
+          </p:cNvPr>
           <p:cNvSpPr/>
           <p:nvPr/>
         </p:nvSpPr>
         <p:spPr>
           <a:xfrm>
-            <a:off x="8138160" y="3200400"/>
+            <a:off x="137160" y="1682496"/>
             <a:ext cx="3657600" cy="3200400"/>
           </a:xfrm>
           <a:prstGeom prst="roundRect">
@@ -58637,25 +59308,32 @@
           <a:lstStyle/>
           <a:p>
             <a:pPr algn="ctr"/>
+            <a:endParaRPr/>
           </a:p>
         </p:txBody>
       </p:sp>
       <p:sp>
         <p:nvSpPr>
-          <p:cNvPr id="16" name="Rectangle 15"/>
+          <p:cNvPr id="40" name="Rectangle 7">
+            <a:extLst>
+              <a:ext uri="{FF2B5EF4-FFF2-40B4-BE49-F238E27FC236}">
+                <a16:creationId xmlns:a16="http://schemas.microsoft.com/office/drawing/2014/main" id="{CF71FF31-31BE-2175-0332-5334D2817D28}"/>
+              </a:ext>
+            </a:extLst>
+          </p:cNvPr>
           <p:cNvSpPr/>
           <p:nvPr/>
         </p:nvSpPr>
         <p:spPr>
           <a:xfrm>
-            <a:off x="8138160" y="3200400"/>
+            <a:off x="137160" y="1682496"/>
             <a:ext cx="38100" cy="3200400"/>
           </a:xfrm>
           <a:prstGeom prst="rect">
             <a:avLst/>
           </a:prstGeom>
           <a:solidFill>
-            <a:srgbClr val="C8102E"/>
+            <a:srgbClr val="58B230"/>
           </a:solidFill>
           <a:ln>
             <a:noFill/>
@@ -58680,18 +59358,25 @@
           <a:lstStyle/>
           <a:p>
             <a:pPr algn="ctr"/>
+            <a:endParaRPr/>
           </a:p>
         </p:txBody>
       </p:sp>
       <p:sp>
         <p:nvSpPr>
-          <p:cNvPr id="17" name="TextBox 16"/>
+          <p:cNvPr id="41" name="TextBox 8">
+            <a:extLst>
+              <a:ext uri="{FF2B5EF4-FFF2-40B4-BE49-F238E27FC236}">
+                <a16:creationId xmlns:a16="http://schemas.microsoft.com/office/drawing/2014/main" id="{C765F31F-0050-F195-55AF-5C9DCBA0E909}"/>
+              </a:ext>
+            </a:extLst>
+          </p:cNvPr>
           <p:cNvSpPr txBox="1"/>
           <p:nvPr/>
         </p:nvSpPr>
         <p:spPr>
           <a:xfrm>
-            <a:off x="8290560" y="3302000"/>
+            <a:off x="289560" y="1784096"/>
             <a:ext cx="3352800" cy="279400"/>
           </a:xfrm>
           <a:prstGeom prst="rect">
@@ -58708,26 +59393,32 @@
             <a:pPr algn="l">
               <a:defRPr sz="1400" b="1">
                 <a:solidFill>
-                  <a:srgbClr val="C8102E"/>
+                  <a:srgbClr val="58B230"/>
                 </a:solidFill>
                 <a:latin typeface="Microsoft YaHei"/>
               </a:defRPr>
             </a:pPr>
             <a:r>
-              <a:t>原则 3: model_runner 零感知</a:t>
+              <a:t>原则 1: Backend 说了算</a:t>
             </a:r>
           </a:p>
         </p:txBody>
       </p:sp>
       <p:sp>
         <p:nvSpPr>
-          <p:cNvPr id="18" name="TextBox 17"/>
+          <p:cNvPr id="42" name="TextBox 9">
+            <a:extLst>
+              <a:ext uri="{FF2B5EF4-FFF2-40B4-BE49-F238E27FC236}">
+                <a16:creationId xmlns:a16="http://schemas.microsoft.com/office/drawing/2014/main" id="{14C21BF9-A304-15B5-9106-FFF4B688690D}"/>
+              </a:ext>
+            </a:extLst>
+          </p:cNvPr>
           <p:cNvSpPr txBox="1"/>
           <p:nvPr/>
         </p:nvSpPr>
         <p:spPr>
           <a:xfrm>
-            <a:off x="8290560" y="3632200"/>
+            <a:off x="289560" y="2114296"/>
             <a:ext cx="3352800" cy="2667000"/>
           </a:xfrm>
           <a:prstGeom prst="rect">
@@ -58753,7 +59444,7 @@
               </a:defRPr>
             </a:pPr>
             <a:r>
-              <a:t>model_runner 不检查 layer_type</a:t>
+              <a:t>KV Cache shape 的唯一决定者是 Backend</a:t>
             </a:r>
           </a:p>
           <a:p>
@@ -58769,7 +59460,7 @@
               </a:defRPr>
             </a:pPr>
             <a:r>
-              <a:t>不判断 use_sparse / use_compress / C8 / A5 / A3</a:t>
+              <a:t>get_kv_cache_shape() 返回完整可用 shape</a:t>
             </a:r>
           </a:p>
           <a:p>
@@ -58785,7 +59476,7 @@
               </a:defRPr>
             </a:pPr>
             <a:r>
-              <a:t>拿到 Spec → 拿到 shape → 分配 → reshape → 结束</a:t>
+              <a:t>每一维的含义、tensor 的数量、K/V 的存储方式</a:t>
             </a:r>
           </a:p>
           <a:p>
@@ -58801,7 +59492,7 @@
               </a:defRPr>
             </a:pPr>
             <a:r>
-              <a:t>→ 所有模型特有逻辑封装在 Spec 子类 + Backend 内</a:t>
+              <a:t>——都由 Backend 封装</a:t>
             </a:r>
           </a:p>
           <a:p>
@@ -58817,48 +59508,17 @@
               </a:defRPr>
             </a:pPr>
             <a:r>
-              <a:t>→ ~60 行代码，0 分支，新增模型不改 model_runner</a:t>
-            </a:r>
-          </a:p>
-        </p:txBody>
-      </p:sp>
-      <p:sp>
-        <p:nvSpPr>
-          <p:cNvPr id="19" name="TextBox 18"/>
-          <p:cNvSpPr txBox="1"/>
-          <p:nvPr/>
-        </p:nvSpPr>
-        <p:spPr>
-          <a:xfrm>
-            <a:off x="548640" y="6492240"/>
-            <a:ext cx="10972800" cy="274320"/>
-          </a:xfrm>
-          <a:prstGeom prst="rect">
-            <a:avLst/>
-          </a:prstGeom>
-          <a:noFill/>
-        </p:spPr>
-        <p:txBody>
-          <a:bodyPr wrap="square">
-            <a:spAutoFit/>
-          </a:bodyPr>
-          <a:lstStyle/>
-          <a:p>
-            <a:pPr algn="ctr">
-              <a:defRPr sz="1100" b="1">
-                <a:solidFill>
-                  <a:srgbClr val="C8102E"/>
-                </a:solidFill>
-                <a:latin typeface="Microsoft YaHei"/>
-              </a:defRPr>
-            </a:pPr>
-            <a:r>
-              <a:t>➜ 接下来我们将逐层对比 Ascend 的实现，看看在每一层上，这三条原则是如何被打破的</a:t>
+              <a:t>→ model_runner 不关心内部怎么拆分</a:t>
             </a:r>
           </a:p>
         </p:txBody>
       </p:sp>
     </p:spTree>
+    <p:extLst>
+      <p:ext uri="{BB962C8B-B14F-4D97-AF65-F5344CB8AC3E}">
+        <p14:creationId xmlns:p14="http://schemas.microsoft.com/office/powerpoint/2010/main" val="3389997563"/>
+      </p:ext>
+    </p:extLst>
   </p:cSld>
   <p:clrMapOvr>
     <a:masterClrMapping/>

</xml_diff>